<commit_message>
Fix closing slide text bleed: reduce font, adjust vertical spacing
</commit_message>
<xml_diff>
--- a/Control_Tower_Sales_Deck.pptx
+++ b/Control_Tower_Sales_Deck.pptx
@@ -24201,7 +24201,7 @@
         </p:nvSpPr>
         <p:spPr>
           <a:xfrm>
-            <a:off x="914400" y="1097280"/>
+            <a:off x="914400" y="731520"/>
             <a:ext cx="10058400" cy="914400"/>
           </a:xfrm>
           <a:prstGeom prst="rect">
@@ -24237,8 +24237,8 @@
         </p:nvSpPr>
         <p:spPr>
           <a:xfrm>
-            <a:off x="1371600" y="2286000"/>
-            <a:ext cx="9144000" cy="2743200"/>
+            <a:off x="1371600" y="1737360"/>
+            <a:ext cx="9144000" cy="3840480"/>
           </a:xfrm>
           <a:prstGeom prst="rect">
             <a:avLst/>
@@ -24252,7 +24252,7 @@
           <a:lstStyle/>
           <a:p>
             <a:pPr algn="ctr">
-              <a:defRPr sz="1700" b="0">
+              <a:defRPr sz="1500" b="0">
                 <a:solidFill>
                   <a:srgbClr val="FFFFFF"/>
                 </a:solidFill>
@@ -24311,7 +24311,7 @@
         </p:nvSpPr>
         <p:spPr>
           <a:xfrm>
-            <a:off x="3657600" y="5394960"/>
+            <a:off x="3657600" y="5669280"/>
             <a:ext cx="4846320" cy="27432"/>
           </a:xfrm>
           <a:prstGeom prst="rect">
@@ -24354,7 +24354,7 @@
         </p:nvSpPr>
         <p:spPr>
           <a:xfrm>
-            <a:off x="914400" y="5669280"/>
+            <a:off x="914400" y="5897880"/>
             <a:ext cx="10058400" cy="731520"/>
           </a:xfrm>
           <a:prstGeom prst="rect">

</xml_diff>